<commit_message>
Updates for 2025 hiring
</commit_message>
<xml_diff>
--- a/Data.Scientist.Case.pptx
+++ b/Data.Scientist.Case.pptx
@@ -341,7 +341,7 @@
             <a:fld id="{1199CC36-1F22-4B1F-8226-858F83A27352}" type="datetimeFigureOut">
               <a:rPr lang="nl-NL" smtClean="0"/>
               <a:pPr/>
-              <a:t>8-12-2022</a:t>
+              <a:t>19-11-2025</a:t>
             </a:fld>
             <a:endParaRPr lang="nl-NL"/>
           </a:p>
@@ -642,6 +642,13 @@
           </p:nvPr>
         </p:nvSpPr>
         <p:spPr/>
+        <p:txBody>
+          <a:bodyPr/>
+          <a:lstStyle/>
+          <a:p>
+            <a:endParaRPr lang="en-GB"/>
+          </a:p>
+        </p:txBody>
       </p:sp>
       <p:sp>
         <p:nvSpPr>
@@ -3819,7 +3826,7 @@
         <p:spPr>
           <a:xfrm>
             <a:off x="662152" y="1413372"/>
-            <a:ext cx="6094948" cy="4547720"/>
+            <a:ext cx="6094948" cy="4790094"/>
           </a:xfrm>
           <a:prstGeom prst="rect">
             <a:avLst/>
@@ -3864,7 +3871,7 @@
                 <a:ea typeface="Open Sans Light" panose="020B0306030504020204" pitchFamily="34" charset="0"/>
                 <a:cs typeface="Poppins Medium"/>
               </a:rPr>
-              <a:t>Our clients can create customized employee surveys including questions based on different topics. Examples of popular HR topics are Employee Engagement and Retention. Topics can be divided into themes and items.</a:t>
+              <a:t>Our clients can create customized employee surveys including questions based on different topics. Examples of popular HR topics are Employee Engagement and Retention. Topics can be divided into themes and items. Most questions have structured responses, but some use open-text responses.</a:t>
             </a:r>
           </a:p>
           <a:p>
@@ -4199,7 +4206,7 @@
         </p:nvSpPr>
         <p:spPr>
           <a:xfrm>
-            <a:off x="7873693" y="3141625"/>
+            <a:off x="7850400" y="2720377"/>
             <a:ext cx="4144492" cy="369332"/>
           </a:xfrm>
           <a:prstGeom prst="rect">
@@ -4219,7 +4226,7 @@
                   <a:schemeClr val="bg1"/>
                 </a:solidFill>
               </a:rPr>
-              <a:t>Product vision</a:t>
+              <a:t>Effectory’s vision</a:t>
             </a:r>
           </a:p>
         </p:txBody>
@@ -4238,8 +4245,8 @@
         </p:nvSpPr>
         <p:spPr>
           <a:xfrm>
-            <a:off x="7873694" y="3431582"/>
-            <a:ext cx="4144492" cy="2709909"/>
+            <a:off x="7873693" y="3030624"/>
+            <a:ext cx="4144492" cy="3210046"/>
           </a:xfrm>
           <a:prstGeom prst="rect">
             <a:avLst/>
@@ -4254,7 +4261,7 @@
           <a:p>
             <a:pPr>
               <a:lnSpc>
-                <a:spcPct val="150000"/>
+                <a:spcPts val="1500"/>
               </a:lnSpc>
               <a:defRPr/>
             </a:pPr>
@@ -4267,31 +4274,40 @@
                 <a:ea typeface="Open Sans Light"/>
                 <a:cs typeface="Poppins Medium"/>
               </a:rPr>
-              <a:t>Effectory is on a mission:</a:t>
-            </a:r>
-            <a:r>
-              <a:rPr lang="en-US" sz="1000" dirty="0">
-                <a:solidFill>
-                  <a:schemeClr val="tx1"/>
-                </a:solidFill>
-                <a:ea typeface="+mn-lt"/>
-                <a:cs typeface="+mn-lt"/>
-              </a:rPr>
-              <a:t> create a better, happier and more productive work environment for everyone, world-wide with valuable interactions throughout the listening cycle, enabling leaders, teams and employees to listen, to learn and to act.</a:t>
+              <a:t>A working world where every voice matters, and every organization thrives.​</a:t>
             </a:r>
           </a:p>
           <a:p>
             <a:pPr>
               <a:lnSpc>
-                <a:spcPct val="150000"/>
+                <a:spcPts val="1500"/>
               </a:lnSpc>
               <a:defRPr/>
             </a:pPr>
-            <a:endParaRPr lang="en-US" sz="1000" dirty="0">
-              <a:latin typeface="Century Gothic"/>
-              <a:ea typeface="+mn-lt"/>
-              <a:cs typeface="+mn-lt"/>
-            </a:endParaRPr>
+            <a:r>
+              <a:rPr lang="en-US" sz="1000" dirty="0">
+                <a:latin typeface="Century Gothic"/>
+                <a:ea typeface="+mn-lt"/>
+                <a:cs typeface="+mn-lt"/>
+              </a:rPr>
+              <a:t>We envision a world where every workplace recognizes that the true strength of their organization lies in their people, actively</a:t>
+            </a:r>
+          </a:p>
+          <a:p>
+            <a:pPr>
+              <a:lnSpc>
+                <a:spcPts val="1500"/>
+              </a:lnSpc>
+              <a:defRPr/>
+            </a:pPr>
+            <a:r>
+              <a:rPr lang="en-US" sz="1000" dirty="0">
+                <a:latin typeface="Century Gothic"/>
+                <a:ea typeface="+mn-lt"/>
+                <a:cs typeface="+mn-lt"/>
+              </a:rPr>
+              <a:t>seeking their ideas and opinions to create better employee experiences and drive organizational success.​</a:t>
+            </a:r>
           </a:p>
           <a:p>
             <a:pPr>
@@ -4309,7 +4325,7 @@
                 <a:ea typeface="+mn-lt"/>
                 <a:cs typeface="+mn-lt"/>
               </a:rPr>
-              <a:t>3 pillars of our platform</a:t>
+              <a:t>Our mission</a:t>
             </a:r>
             <a:endParaRPr lang="en-US" dirty="0">
               <a:latin typeface="Century Gothic"/>
@@ -4320,7 +4336,7 @@
           <a:p>
             <a:pPr marL="0" marR="0" lvl="0" indent="0" algn="l" defTabSz="914400" rtl="0" eaLnBrk="1" fontAlgn="auto" latinLnBrk="0" hangingPunct="1">
               <a:lnSpc>
-                <a:spcPct val="100000"/>
+                <a:spcPts val="1500"/>
               </a:lnSpc>
               <a:spcBef>
                 <a:spcPts val="0"/>
@@ -4344,118 +4360,39 @@
                 <a:ea typeface="+mn-lt"/>
                 <a:cs typeface="+mn-lt"/>
               </a:rPr>
-              <a:t>Listen.</a:t>
-            </a:r>
-            <a:r>
-              <a:rPr lang="en-US" sz="1000" dirty="0">
-                <a:solidFill>
-                  <a:schemeClr val="tx1"/>
-                </a:solidFill>
-                <a:latin typeface="Century Gothic"/>
-                <a:ea typeface="+mn-lt"/>
-                <a:cs typeface="+mn-lt"/>
-              </a:rPr>
-              <a:t> </a:t>
-            </a:r>
-            <a:r>
-              <a:rPr lang="en-US" sz="1000" dirty="0">
-                <a:latin typeface="Century Gothic" panose="020F0302020204030204"/>
-              </a:rPr>
-              <a:t>All coordinators can listen quickly, easily and flexibly.</a:t>
-            </a:r>
-            <a:endParaRPr lang="en-US" sz="1000" dirty="0">
-              <a:solidFill>
-                <a:schemeClr val="tx1"/>
-              </a:solidFill>
-              <a:latin typeface="Century Gothic"/>
-              <a:ea typeface="Open Sans Light"/>
-              <a:cs typeface="Poppins Medium"/>
-            </a:endParaRPr>
-          </a:p>
-          <a:p>
-            <a:pPr>
+              <a:t>To build meaningful organizations with the voice of every employee.</a:t>
+            </a:r>
+          </a:p>
+          <a:p>
+            <a:pPr marL="0" marR="0" lvl="0" indent="0" algn="l" defTabSz="914400" rtl="0" eaLnBrk="1" fontAlgn="auto" latinLnBrk="0" hangingPunct="1">
               <a:lnSpc>
-                <a:spcPct val="150000"/>
+                <a:spcPts val="1500"/>
               </a:lnSpc>
+              <a:spcBef>
+                <a:spcPts val="0"/>
+              </a:spcBef>
+              <a:spcAft>
+                <a:spcPts val="0"/>
+              </a:spcAft>
+              <a:buClrTx/>
+              <a:buSzTx/>
+              <a:buFontTx/>
+              <a:buNone/>
+              <a:tabLst/>
               <a:defRPr/>
             </a:pPr>
             <a:r>
-              <a:rPr lang="en-US" sz="1000" b="1" dirty="0">
-                <a:latin typeface="Century Gothic"/>
-                <a:ea typeface="Open Sans Light"/>
-                <a:cs typeface="Poppins Medium"/>
-              </a:rPr>
-              <a:t>Learn.</a:t>
-            </a:r>
-            <a:r>
-              <a:rPr lang="en-US" sz="1000" dirty="0">
-                <a:latin typeface="Century Gothic"/>
-                <a:ea typeface="Open Sans Light"/>
-                <a:cs typeface="Poppins Medium"/>
-              </a:rPr>
-              <a:t> </a:t>
-            </a:r>
-            <a:r>
-              <a:rPr lang="en-US" sz="1000" dirty="0">
+              <a:rPr kumimoji="0" lang="en-US" sz="1000" i="0" u="none" strike="noStrike" kern="1200" cap="none" spc="0" normalizeH="0" baseline="0" noProof="0" dirty="0">
+                <a:ln>
+                  <a:noFill/>
+                </a:ln>
+                <a:effectLst/>
+                <a:uLnTx/>
+                <a:uFillTx/>
                 <a:latin typeface="Century Gothic" panose="020F0302020204030204"/>
               </a:rPr>
-              <a:t>Dynamic insights that are relevant and actionable.</a:t>
-            </a:r>
-            <a:endParaRPr kumimoji="0" lang="en-US" sz="1000" i="0" u="none" strike="noStrike" kern="1200" cap="none" spc="0" normalizeH="0" baseline="0" noProof="0" dirty="0">
-              <a:ln>
-                <a:noFill/>
-              </a:ln>
-              <a:effectLst/>
-              <a:uLnTx/>
-              <a:uFillTx/>
-              <a:latin typeface="Century Gothic" panose="020F0302020204030204"/>
-            </a:endParaRPr>
-          </a:p>
-          <a:p>
-            <a:pPr>
-              <a:lnSpc>
-                <a:spcPct val="150000"/>
-              </a:lnSpc>
-              <a:defRPr/>
-            </a:pPr>
-            <a:r>
-              <a:rPr lang="en-US" sz="1000" b="1" dirty="0">
-                <a:latin typeface="Century Gothic" panose="020F0302020204030204"/>
-              </a:rPr>
-              <a:t>Lead.</a:t>
-            </a:r>
-            <a:r>
-              <a:rPr lang="en-US" sz="1000" dirty="0">
-                <a:latin typeface="Century Gothic" panose="020F0302020204030204"/>
-              </a:rPr>
-              <a:t> Inspiration to act and to improve on all levels.</a:t>
-            </a:r>
-            <a:endParaRPr kumimoji="0" lang="en-US" sz="1000" i="0" u="none" strike="noStrike" kern="1200" cap="none" spc="0" normalizeH="0" baseline="0" noProof="0" dirty="0">
-              <a:ln>
-                <a:noFill/>
-              </a:ln>
-              <a:effectLst/>
-              <a:uLnTx/>
-              <a:uFillTx/>
-              <a:latin typeface="Century Gothic" panose="020F0302020204030204"/>
-            </a:endParaRPr>
-          </a:p>
-          <a:p>
-            <a:pPr>
-              <a:lnSpc>
-                <a:spcPct val="150000"/>
-              </a:lnSpc>
-              <a:defRPr/>
-            </a:pPr>
-            <a:endParaRPr kumimoji="0" lang="en-US" sz="1000" i="0" u="none" strike="noStrike" kern="1200" cap="none" spc="0" normalizeH="0" baseline="0" noProof="0" dirty="0">
-              <a:ln>
-                <a:noFill/>
-              </a:ln>
-              <a:effectLst/>
-              <a:uLnTx/>
-              <a:uFillTx/>
-              <a:latin typeface="Century Gothic" panose="020F0302020204030204"/>
-            </a:endParaRPr>
+              <a:t>We empower organizations to truly understand their people, ensuring they feel heard and supported. Through actionable insights and expert guidance, we help create workplaces where engagement and productivity thrive, driving success for both people and organizations.</a:t>
+            </a:r>
           </a:p>
           <a:p>
             <a:pPr>
@@ -4528,8 +4465,8 @@
         </p:nvSpPr>
         <p:spPr>
           <a:xfrm>
-            <a:off x="7850400" y="1014228"/>
-            <a:ext cx="4191225" cy="2031325"/>
+            <a:off x="7873693" y="886635"/>
+            <a:ext cx="4191225" cy="1892826"/>
           </a:xfrm>
           <a:prstGeom prst="rect">
             <a:avLst/>
@@ -4543,39 +4480,39 @@
           <a:lstStyle/>
           <a:p>
             <a:r>
-              <a:rPr lang="en-US" sz="900" b="1">
+              <a:rPr lang="en-US" sz="900" b="1" dirty="0">
                 <a:solidFill>
                   <a:srgbClr val="192743"/>
                 </a:solidFill>
                 <a:ea typeface="+mn-lt"/>
                 <a:cs typeface="+mn-lt"/>
               </a:rPr>
-              <a:t>A few days before the  case</a:t>
+              <a:t>A few days before the case</a:t>
             </a:r>
             <a:br>
-              <a:rPr lang="en-US" sz="900"/>
+              <a:rPr lang="en-US" sz="900" dirty="0"/>
             </a:br>
             <a:r>
-              <a:rPr lang="en-US" sz="900">
+              <a:rPr lang="en-US" sz="900" dirty="0">
                 <a:solidFill>
                   <a:srgbClr val="192743"/>
                 </a:solidFill>
               </a:rPr>
-              <a:t>n.a.       | You receive the briefing from Effectory</a:t>
-            </a:r>
-          </a:p>
-          <a:p>
-            <a:r>
-              <a:rPr lang="en-US" sz="900">
+              <a:t>- You receive the briefing from Effectory</a:t>
+            </a:r>
+          </a:p>
+          <a:p>
+            <a:r>
+              <a:rPr lang="en-US" sz="900" dirty="0">
                 <a:solidFill>
                   <a:srgbClr val="192743"/>
                 </a:solidFill>
               </a:rPr>
-              <a:t>n.a.       | You read up on the case and prepare solution</a:t>
-            </a:r>
-          </a:p>
-          <a:p>
-            <a:endParaRPr lang="en-US" sz="900">
+              <a:t>- You read up on the case and prepare solution</a:t>
+            </a:r>
+          </a:p>
+          <a:p>
+            <a:endParaRPr lang="en-US" sz="900" dirty="0">
               <a:solidFill>
                 <a:srgbClr val="192743"/>
               </a:solidFill>
@@ -4583,42 +4520,35 @@
           </a:p>
           <a:p>
             <a:r>
-              <a:rPr lang="en-US" sz="900" b="1">
-                <a:solidFill>
-                  <a:srgbClr val="192743"/>
-                </a:solidFill>
-              </a:rPr>
-              <a:t>Day before the case (24h in advance)</a:t>
-            </a:r>
-          </a:p>
-          <a:p>
-            <a:r>
-              <a:rPr lang="en-US" sz="900">
-                <a:solidFill>
-                  <a:srgbClr val="192743"/>
-                </a:solidFill>
-              </a:rPr>
-              <a:t>n.a.        | You provide your notebook for review</a:t>
-            </a:r>
-          </a:p>
-          <a:p>
-            <a:endParaRPr lang="en-US" sz="900">
-              <a:solidFill>
-                <a:srgbClr val="192743"/>
-              </a:solidFill>
-            </a:endParaRPr>
-          </a:p>
-          <a:p>
-            <a:br>
-              <a:rPr lang="en-US" sz="900"/>
-            </a:br>
-            <a:r>
               <a:rPr lang="en-US" sz="900" b="1" dirty="0">
                 <a:solidFill>
                   <a:srgbClr val="192743"/>
                 </a:solidFill>
               </a:rPr>
-              <a:t>Day of case </a:t>
+              <a:t>The day before the case (24h in advance)</a:t>
+            </a:r>
+          </a:p>
+          <a:p>
+            <a:r>
+              <a:rPr lang="en-US" sz="900" dirty="0">
+                <a:solidFill>
+                  <a:srgbClr val="192743"/>
+                </a:solidFill>
+              </a:rPr>
+              <a:t>- You provide your notebook for review</a:t>
+            </a:r>
+          </a:p>
+          <a:p>
+            <a:br>
+              <a:rPr lang="en-US" sz="900" dirty="0"/>
+            </a:br>
+            <a:r>
+              <a:rPr lang="en-US" sz="900" b="1" dirty="0">
+                <a:solidFill>
+                  <a:srgbClr val="192743"/>
+                </a:solidFill>
+              </a:rPr>
+              <a:t>On the day of the case </a:t>
             </a:r>
           </a:p>
           <a:p>
@@ -4795,7 +4725,7 @@
         <p:spPr>
           <a:xfrm>
             <a:off x="662152" y="1394523"/>
-            <a:ext cx="6094948" cy="5300362"/>
+            <a:ext cx="6094948" cy="4530920"/>
           </a:xfrm>
           <a:prstGeom prst="rect">
             <a:avLst/>
@@ -4815,17 +4745,6 @@
               <a:defRPr/>
             </a:pPr>
             <a:r>
-              <a:rPr lang="nl-NL" b="1" dirty="0" err="1">
-                <a:solidFill>
-                  <a:srgbClr val="192743"/>
-                </a:solidFill>
-                <a:latin typeface="Century Gothic"/>
-                <a:ea typeface="Open Sans Light"/>
-                <a:cs typeface="Poppins Medium"/>
-              </a:rPr>
-              <a:t>What</a:t>
-            </a:r>
-            <a:r>
               <a:rPr lang="nl-NL" b="1" dirty="0">
                 <a:solidFill>
                   <a:srgbClr val="192743"/>
@@ -4834,49 +4753,8 @@
                 <a:ea typeface="Open Sans Light"/>
                 <a:cs typeface="Poppins Medium"/>
               </a:rPr>
-              <a:t> is </a:t>
-            </a:r>
-            <a:r>
-              <a:rPr lang="nl-NL" b="1" dirty="0" err="1">
-                <a:solidFill>
-                  <a:srgbClr val="192743"/>
-                </a:solidFill>
-                <a:latin typeface="Century Gothic"/>
-                <a:ea typeface="Open Sans Light"/>
-                <a:cs typeface="Poppins Medium"/>
-              </a:rPr>
-              <a:t>expected</a:t>
-            </a:r>
-            <a:r>
-              <a:rPr lang="nl-NL" b="1" dirty="0">
-                <a:solidFill>
-                  <a:srgbClr val="192743"/>
-                </a:solidFill>
-                <a:latin typeface="Century Gothic"/>
-                <a:ea typeface="Open Sans Light"/>
-                <a:cs typeface="Poppins Medium"/>
-              </a:rPr>
-              <a:t> of </a:t>
-            </a:r>
-            <a:r>
-              <a:rPr lang="nl-NL" b="1" dirty="0" err="1">
-                <a:solidFill>
-                  <a:srgbClr val="192743"/>
-                </a:solidFill>
-                <a:latin typeface="Century Gothic"/>
-                <a:ea typeface="Open Sans Light"/>
-                <a:cs typeface="Poppins Medium"/>
-              </a:rPr>
-              <a:t>you</a:t>
-            </a:r>
-            <a:endParaRPr lang="nl-NL" b="1" dirty="0">
-              <a:solidFill>
-                <a:srgbClr val="192743"/>
-              </a:solidFill>
-              <a:latin typeface="Century Gothic"/>
-              <a:ea typeface="Open Sans Light"/>
-              <a:cs typeface="Poppins Medium"/>
-            </a:endParaRPr>
+              <a:t>What is expected of you</a:t>
+            </a:r>
           </a:p>
           <a:p>
             <a:endParaRPr lang="en-US" sz="1000" i="1" u="sng" dirty="0"/>
@@ -4897,25 +4775,7 @@
                 <a:ea typeface="Calibri" panose="020F0502020204030204" pitchFamily="34" charset="0"/>
                 <a:cs typeface="Times New Roman" panose="02020603050405020304" pitchFamily="18" charset="0"/>
               </a:rPr>
-              <a:t>With Python/</a:t>
-            </a:r>
-            <a:r>
-              <a:rPr lang="en-US" sz="1000" dirty="0" err="1">
-                <a:effectLst/>
-                <a:latin typeface="+mj-lt"/>
-                <a:ea typeface="Calibri" panose="020F0502020204030204" pitchFamily="34" charset="0"/>
-                <a:cs typeface="Times New Roman" panose="02020603050405020304" pitchFamily="18" charset="0"/>
-              </a:rPr>
-              <a:t>Jupyter</a:t>
-            </a:r>
-            <a:r>
-              <a:rPr lang="en-US" sz="1000" dirty="0">
-                <a:effectLst/>
-                <a:latin typeface="+mj-lt"/>
-                <a:ea typeface="Calibri" panose="020F0502020204030204" pitchFamily="34" charset="0"/>
-                <a:cs typeface="Times New Roman" panose="02020603050405020304" pitchFamily="18" charset="0"/>
-              </a:rPr>
-              <a:t> Notebook solve this case.</a:t>
+              <a:t>Use Jupyter Notebook with Python. </a:t>
             </a:r>
           </a:p>
           <a:p>
@@ -4934,7 +4794,7 @@
                 <a:ea typeface="Calibri" panose="020F0502020204030204" pitchFamily="34" charset="0"/>
                 <a:cs typeface="Times New Roman" panose="02020603050405020304" pitchFamily="18" charset="0"/>
               </a:rPr>
-              <a:t>As part of this case, you are provided with a </a:t>
+              <a:t>You are provided with a </a:t>
             </a:r>
             <a:r>
               <a:rPr lang="en-US" sz="1000" i="1" dirty="0">
@@ -4960,8 +4820,188 @@
                 <a:ea typeface="Calibri" panose="020F0502020204030204" pitchFamily="34" charset="0"/>
                 <a:cs typeface="Times New Roman" panose="02020603050405020304" pitchFamily="18" charset="0"/>
               </a:rPr>
-              <a:t>that represent the answers to a survey by a fictional client called ‘The Organization’. The questions below are the ones that you should have solutions for in your notebook. We will ask you explain what you have done in your notebooks and why. </a:t>
-            </a:r>
+              <a:t>with the answers to a survey by a fictional client called ‘The Organization’. We will ask you explain what you have done in your notebooks and why. </a:t>
+            </a:r>
+            <a:r>
+              <a:rPr lang="en-US" sz="1000" dirty="0">
+                <a:ea typeface="Calibri" panose="020F0502020204030204" pitchFamily="34" charset="0"/>
+                <a:cs typeface="Times New Roman" panose="02020603050405020304" pitchFamily="18" charset="0"/>
+              </a:rPr>
+              <a:t>Your notebook should address the questions below:</a:t>
+            </a:r>
+            <a:endParaRPr lang="en-US" sz="1000" dirty="0">
+              <a:effectLst/>
+              <a:latin typeface="+mj-lt"/>
+              <a:ea typeface="Calibri" panose="020F0502020204030204" pitchFamily="34" charset="0"/>
+              <a:cs typeface="Times New Roman" panose="02020603050405020304" pitchFamily="18" charset="0"/>
+            </a:endParaRPr>
+          </a:p>
+          <a:p>
+            <a:pPr marL="342900" lvl="0" indent="-342900">
+              <a:lnSpc>
+                <a:spcPct val="150000"/>
+              </a:lnSpc>
+              <a:buFont typeface="+mj-lt"/>
+              <a:buAutoNum type="arabicPeriod"/>
+            </a:pPr>
+            <a:r>
+              <a:rPr lang="en-US" sz="1000" dirty="0">
+                <a:effectLst/>
+                <a:latin typeface="+mj-lt"/>
+                <a:ea typeface="Calibri" panose="020F0502020204030204" pitchFamily="34" charset="0"/>
+                <a:cs typeface="Times New Roman" panose="02020603050405020304" pitchFamily="18" charset="0"/>
+              </a:rPr>
+              <a:t>Overall Performance</a:t>
+            </a:r>
+          </a:p>
+          <a:p>
+            <a:pPr marL="800100" lvl="1" indent="-342900">
+              <a:lnSpc>
+                <a:spcPct val="150000"/>
+              </a:lnSpc>
+              <a:buFont typeface="+mj-lt"/>
+              <a:buAutoNum type="alphaLcPeriod"/>
+            </a:pPr>
+            <a:r>
+              <a:rPr lang="en-US" sz="1000" dirty="0">
+                <a:effectLst/>
+                <a:latin typeface="+mj-lt"/>
+                <a:ea typeface="Calibri" panose="020F0502020204030204" pitchFamily="34" charset="0"/>
+                <a:cs typeface="Times New Roman" panose="02020603050405020304" pitchFamily="18" charset="0"/>
+              </a:rPr>
+              <a:t>How would you assess how The Organization is performing on this survey?</a:t>
+            </a:r>
+          </a:p>
+          <a:p>
+            <a:pPr marL="800100" lvl="1" indent="-342900">
+              <a:lnSpc>
+                <a:spcPct val="150000"/>
+              </a:lnSpc>
+              <a:buFont typeface="+mj-lt"/>
+              <a:buAutoNum type="alphaLcPeriod"/>
+            </a:pPr>
+            <a:r>
+              <a:rPr lang="en-US" sz="1000" dirty="0">
+                <a:effectLst/>
+                <a:latin typeface="+mj-lt"/>
+                <a:ea typeface="Calibri" panose="020F0502020204030204" pitchFamily="34" charset="0"/>
+                <a:cs typeface="Times New Roman" panose="02020603050405020304" pitchFamily="18" charset="0"/>
+              </a:rPr>
+              <a:t>Include descriptive statistics and visualizations to support your conclusions.</a:t>
+            </a:r>
+          </a:p>
+          <a:p>
+            <a:pPr marL="342900" indent="-342900">
+              <a:lnSpc>
+                <a:spcPct val="150000"/>
+              </a:lnSpc>
+              <a:buFont typeface="+mj-lt"/>
+              <a:buAutoNum type="arabicPeriod"/>
+            </a:pPr>
+            <a:r>
+              <a:rPr lang="en-US" sz="1000" dirty="0">
+                <a:effectLst/>
+                <a:latin typeface="+mj-lt"/>
+                <a:ea typeface="Calibri" panose="020F0502020204030204" pitchFamily="34" charset="0"/>
+                <a:cs typeface="Times New Roman" panose="02020603050405020304" pitchFamily="18" charset="0"/>
+              </a:rPr>
+              <a:t>Actionable Insights</a:t>
+            </a:r>
+          </a:p>
+          <a:p>
+            <a:pPr marL="800100" lvl="1" indent="-342900">
+              <a:lnSpc>
+                <a:spcPct val="150000"/>
+              </a:lnSpc>
+              <a:buFont typeface="+mj-lt"/>
+              <a:buAutoNum type="alphaLcPeriod"/>
+            </a:pPr>
+            <a:r>
+              <a:rPr lang="en-US" sz="1000" dirty="0">
+                <a:effectLst/>
+                <a:latin typeface="+mj-lt"/>
+                <a:ea typeface="Calibri" panose="020F0502020204030204" pitchFamily="34" charset="0"/>
+                <a:cs typeface="Times New Roman" panose="02020603050405020304" pitchFamily="18" charset="0"/>
+              </a:rPr>
+              <a:t>Suggest how managers can improve in their specific problem areas.</a:t>
+            </a:r>
+          </a:p>
+          <a:p>
+            <a:pPr marL="800100" lvl="1" indent="-342900">
+              <a:lnSpc>
+                <a:spcPct val="150000"/>
+              </a:lnSpc>
+              <a:buFont typeface="+mj-lt"/>
+              <a:buAutoNum type="alphaLcPeriod"/>
+            </a:pPr>
+            <a:r>
+              <a:rPr lang="en-US" sz="1000" dirty="0">
+                <a:effectLst/>
+                <a:latin typeface="+mj-lt"/>
+                <a:ea typeface="Calibri" panose="020F0502020204030204" pitchFamily="34" charset="0"/>
+                <a:cs typeface="Times New Roman" panose="02020603050405020304" pitchFamily="18" charset="0"/>
+              </a:rPr>
+              <a:t>Identify which factors most strongly relate to increased intention to leave (QuestionId: 3250780).</a:t>
+            </a:r>
+          </a:p>
+          <a:p>
+            <a:pPr marL="342900" indent="-342900">
+              <a:lnSpc>
+                <a:spcPct val="150000"/>
+              </a:lnSpc>
+              <a:buFont typeface="+mj-lt"/>
+              <a:buAutoNum type="arabicPeriod"/>
+            </a:pPr>
+            <a:r>
+              <a:rPr lang="en-US" sz="1000" dirty="0">
+                <a:effectLst/>
+                <a:latin typeface="+mj-lt"/>
+                <a:ea typeface="Calibri" panose="020F0502020204030204" pitchFamily="34" charset="0"/>
+                <a:cs typeface="Times New Roman" panose="02020603050405020304" pitchFamily="18" charset="0"/>
+              </a:rPr>
+              <a:t>Text Analysis of the open-text responses:</a:t>
+            </a:r>
+          </a:p>
+          <a:p>
+            <a:pPr marL="800100" lvl="1" indent="-342900">
+              <a:lnSpc>
+                <a:spcPct val="150000"/>
+              </a:lnSpc>
+              <a:buFont typeface="+mj-lt"/>
+              <a:buAutoNum type="alphaLcPeriod"/>
+            </a:pPr>
+            <a:r>
+              <a:rPr lang="en-US" sz="1000" dirty="0">
+                <a:effectLst/>
+                <a:latin typeface="+mj-lt"/>
+                <a:ea typeface="Calibri" panose="020F0502020204030204" pitchFamily="34" charset="0"/>
+                <a:cs typeface="Times New Roman" panose="02020603050405020304" pitchFamily="18" charset="0"/>
+              </a:rPr>
+              <a:t>Summarize key topics and sentiments.</a:t>
+            </a:r>
+          </a:p>
+          <a:p>
+            <a:pPr marL="800100" lvl="1" indent="-342900">
+              <a:lnSpc>
+                <a:spcPct val="150000"/>
+              </a:lnSpc>
+              <a:buFont typeface="+mj-lt"/>
+              <a:buAutoNum type="alphaLcPeriod"/>
+            </a:pPr>
+            <a:r>
+              <a:rPr lang="en-US" sz="1000" dirty="0">
+                <a:effectLst/>
+                <a:latin typeface="+mj-lt"/>
+                <a:ea typeface="Calibri" panose="020F0502020204030204" pitchFamily="34" charset="0"/>
+                <a:cs typeface="Times New Roman" panose="02020603050405020304" pitchFamily="18" charset="0"/>
+              </a:rPr>
+              <a:t>Identify patterns or anomalies in comparison with the structured data.</a:t>
+            </a:r>
+            <a:endParaRPr lang="en-US" sz="1000" dirty="0">
+              <a:latin typeface="+mj-lt"/>
+              <a:ea typeface="Calibri" panose="020F0502020204030204" pitchFamily="34" charset="0"/>
+              <a:cs typeface="Times New Roman" panose="02020603050405020304" pitchFamily="18" charset="0"/>
+            </a:endParaRPr>
           </a:p>
           <a:p>
             <a:pPr>
@@ -4972,156 +5012,20 @@
                 <a:spcPts val="800"/>
               </a:spcAft>
             </a:pPr>
-            <a:r>
-              <a:rPr lang="en-US" sz="1000" dirty="0">
-                <a:effectLst/>
-                <a:latin typeface="+mj-lt"/>
-                <a:ea typeface="Calibri" panose="020F0502020204030204" pitchFamily="34" charset="0"/>
-                <a:cs typeface="Times New Roman" panose="02020603050405020304" pitchFamily="18" charset="0"/>
-              </a:rPr>
-              <a:t>The questions on the right (Discussion questions) we can discuss in person on the day of the case. </a:t>
-            </a:r>
-          </a:p>
-          <a:p>
-            <a:pPr>
-              <a:lnSpc>
-                <a:spcPct val="150000"/>
-              </a:lnSpc>
-              <a:spcAft>
-                <a:spcPts val="800"/>
-              </a:spcAft>
-            </a:pPr>
-            <a:r>
-              <a:rPr lang="en-US" sz="1000" dirty="0">
-                <a:effectLst/>
-                <a:latin typeface="+mj-lt"/>
-                <a:ea typeface="Calibri" panose="020F0502020204030204" pitchFamily="34" charset="0"/>
-                <a:cs typeface="Times New Roman" panose="02020603050405020304" pitchFamily="18" charset="0"/>
-              </a:rPr>
-              <a:t>Based on a sample of client data:</a:t>
-            </a:r>
-          </a:p>
-          <a:p>
-            <a:pPr marL="342900" lvl="0" indent="-342900">
-              <a:lnSpc>
-                <a:spcPct val="150000"/>
-              </a:lnSpc>
-              <a:buFont typeface="+mj-lt"/>
-              <a:buAutoNum type="arabicPeriod"/>
-            </a:pPr>
-            <a:r>
-              <a:rPr lang="en-US" sz="1000" dirty="0">
-                <a:effectLst/>
-                <a:latin typeface="+mj-lt"/>
-                <a:ea typeface="Calibri" panose="020F0502020204030204" pitchFamily="34" charset="0"/>
-                <a:cs typeface="Times New Roman" panose="02020603050405020304" pitchFamily="18" charset="0"/>
-              </a:rPr>
-              <a:t>What would be your approach to see how The Organization is performing on this survey?</a:t>
-            </a:r>
-          </a:p>
-          <a:p>
-            <a:pPr marL="342900" lvl="0" indent="-342900">
-              <a:lnSpc>
-                <a:spcPct val="150000"/>
-              </a:lnSpc>
-              <a:buFont typeface="+mj-lt"/>
-              <a:buAutoNum type="arabicPeriod"/>
-            </a:pPr>
-            <a:r>
-              <a:rPr lang="en-US" sz="1000" dirty="0">
-                <a:effectLst/>
-                <a:latin typeface="+mj-lt"/>
-                <a:ea typeface="Calibri" panose="020F0502020204030204" pitchFamily="34" charset="0"/>
-                <a:cs typeface="Times New Roman" panose="02020603050405020304" pitchFamily="18" charset="0"/>
-              </a:rPr>
-              <a:t>Managers of The Organization are interested in suggestions how they can improve in their specific problem areas.</a:t>
-            </a:r>
-          </a:p>
-          <a:p>
-            <a:pPr marL="342900" lvl="0" indent="-342900">
-              <a:lnSpc>
-                <a:spcPct val="150000"/>
-              </a:lnSpc>
-              <a:buFont typeface="+mj-lt"/>
-              <a:buAutoNum type="arabicPeriod"/>
-            </a:pPr>
-            <a:r>
-              <a:rPr lang="en-US" sz="1000" dirty="0">
-                <a:effectLst/>
-                <a:latin typeface="+mj-lt"/>
-                <a:ea typeface="Calibri" panose="020F0502020204030204" pitchFamily="34" charset="0"/>
-                <a:cs typeface="Times New Roman" panose="02020603050405020304" pitchFamily="18" charset="0"/>
-              </a:rPr>
-              <a:t>The client The Organization is interested in what factors contribute to increased intention to leave The Organization (</a:t>
-            </a:r>
-            <a:r>
-              <a:rPr lang="en-US" sz="1000" dirty="0" err="1">
-                <a:effectLst/>
-                <a:latin typeface="+mj-lt"/>
-                <a:ea typeface="Calibri" panose="020F0502020204030204" pitchFamily="34" charset="0"/>
-                <a:cs typeface="Times New Roman" panose="02020603050405020304" pitchFamily="18" charset="0"/>
-              </a:rPr>
-              <a:t>QuestionId</a:t>
-            </a:r>
-            <a:r>
-              <a:rPr lang="en-US" sz="1000" dirty="0">
-                <a:effectLst/>
-                <a:latin typeface="+mj-lt"/>
-                <a:ea typeface="Calibri" panose="020F0502020204030204" pitchFamily="34" charset="0"/>
-                <a:cs typeface="Times New Roman" panose="02020603050405020304" pitchFamily="18" charset="0"/>
-              </a:rPr>
-              <a:t>: 3250780; item: “I have taken serious action to look for another job over the past three months, or plan to do so in the next three months”)</a:t>
-            </a:r>
-          </a:p>
-          <a:p>
-            <a:pPr marL="342900" lvl="0" indent="-342900">
-              <a:lnSpc>
-                <a:spcPct val="150000"/>
-              </a:lnSpc>
-              <a:buFont typeface="+mj-lt"/>
-              <a:buAutoNum type="arabicPeriod"/>
-            </a:pPr>
-            <a:r>
-              <a:rPr lang="en-US" sz="1000" dirty="0">
-                <a:effectLst/>
-                <a:latin typeface="+mj-lt"/>
-                <a:ea typeface="Calibri" panose="020F0502020204030204" pitchFamily="34" charset="0"/>
-                <a:cs typeface="Times New Roman" panose="02020603050405020304" pitchFamily="18" charset="0"/>
-              </a:rPr>
-              <a:t>Managers of The Organization would like to know what margin do you see in the data for them to improve their theme scores for the next survey.</a:t>
-            </a:r>
-          </a:p>
-          <a:p>
-            <a:pPr>
-              <a:lnSpc>
-                <a:spcPct val="150000"/>
-              </a:lnSpc>
-              <a:spcAft>
-                <a:spcPts val="800"/>
-              </a:spcAft>
-            </a:pPr>
-            <a:endParaRPr lang="en-US" sz="1000" dirty="0">
-              <a:latin typeface="+mj-lt"/>
-              <a:ea typeface="Calibri" panose="020F0502020204030204" pitchFamily="34" charset="0"/>
-              <a:cs typeface="Times New Roman" panose="02020603050405020304" pitchFamily="18" charset="0"/>
-            </a:endParaRPr>
-          </a:p>
-          <a:p>
-            <a:pPr>
-              <a:lnSpc>
-                <a:spcPct val="150000"/>
-              </a:lnSpc>
-              <a:spcAft>
-                <a:spcPts val="800"/>
-              </a:spcAft>
-            </a:pPr>
-            <a:r>
+            <a:br>
               <a:rPr lang="en-US" sz="1000" dirty="0">
                 <a:latin typeface="+mj-lt"/>
                 <a:ea typeface="Calibri" panose="020F0502020204030204" pitchFamily="34" charset="0"/>
                 <a:cs typeface="Times New Roman" panose="02020603050405020304" pitchFamily="18" charset="0"/>
               </a:rPr>
-              <a:t>We recommend you to spend 4-6 hours on this case</a:t>
+            </a:br>
+            <a:r>
+              <a:rPr lang="en-US" sz="1000" dirty="0">
+                <a:latin typeface="+mj-lt"/>
+                <a:ea typeface="Calibri" panose="020F0502020204030204" pitchFamily="34" charset="0"/>
+                <a:cs typeface="Times New Roman" panose="02020603050405020304" pitchFamily="18" charset="0"/>
+              </a:rPr>
+              <a:t>We recommend that you spend 4-6 hours on this case</a:t>
             </a:r>
           </a:p>
         </p:txBody>
@@ -5193,7 +5097,7 @@
         <p:spPr>
           <a:xfrm>
             <a:off x="7873693" y="1394523"/>
-            <a:ext cx="4144492" cy="3245760"/>
+            <a:ext cx="4144492" cy="4700005"/>
           </a:xfrm>
           <a:prstGeom prst="rect">
             <a:avLst/>
@@ -5215,18 +5119,6 @@
               </a:spcAft>
             </a:pPr>
             <a:r>
-              <a:rPr lang="nl-NL" b="1" dirty="0" err="1">
-                <a:solidFill>
-                  <a:srgbClr val="FEFDFA"/>
-                </a:solidFill>
-                <a:effectLst/>
-                <a:latin typeface="+mj-lt"/>
-                <a:ea typeface="Calibri" panose="020F0502020204030204" pitchFamily="34" charset="0"/>
-                <a:cs typeface="Times New Roman" panose="02020603050405020304" pitchFamily="18" charset="0"/>
-              </a:rPr>
-              <a:t>Discussion</a:t>
-            </a:r>
-            <a:r>
               <a:rPr lang="nl-NL" b="1" dirty="0">
                 <a:solidFill>
                   <a:srgbClr val="FEFDFA"/>
@@ -5236,31 +5128,7 @@
                 <a:ea typeface="Calibri" panose="020F0502020204030204" pitchFamily="34" charset="0"/>
                 <a:cs typeface="Times New Roman" panose="02020603050405020304" pitchFamily="18" charset="0"/>
               </a:rPr>
-              <a:t> </a:t>
-            </a:r>
-            <a:r>
-              <a:rPr lang="nl-NL" b="1" dirty="0" err="1">
-                <a:solidFill>
-                  <a:srgbClr val="FEFDFA"/>
-                </a:solidFill>
-                <a:effectLst/>
-                <a:latin typeface="+mj-lt"/>
-                <a:ea typeface="Calibri" panose="020F0502020204030204" pitchFamily="34" charset="0"/>
-                <a:cs typeface="Times New Roman" panose="02020603050405020304" pitchFamily="18" charset="0"/>
-              </a:rPr>
-              <a:t>questions</a:t>
-            </a:r>
-            <a:r>
-              <a:rPr lang="nl-NL" b="1" dirty="0">
-                <a:solidFill>
-                  <a:srgbClr val="FEFDFA"/>
-                </a:solidFill>
-                <a:effectLst/>
-                <a:latin typeface="+mj-lt"/>
-                <a:ea typeface="Calibri" panose="020F0502020204030204" pitchFamily="34" charset="0"/>
-                <a:cs typeface="Times New Roman" panose="02020603050405020304" pitchFamily="18" charset="0"/>
-              </a:rPr>
-              <a:t>:</a:t>
+              <a:t>Discussion questions:</a:t>
             </a:r>
             <a:endParaRPr lang="en-US" b="1" dirty="0">
               <a:solidFill>
@@ -5273,6 +5141,40 @@
             </a:endParaRPr>
           </a:p>
           <a:p>
+            <a:pPr lvl="0">
+              <a:lnSpc>
+                <a:spcPct val="150000"/>
+              </a:lnSpc>
+            </a:pPr>
+            <a:r>
+              <a:rPr lang="en-US" sz="1050" i="1" dirty="0">
+                <a:latin typeface="+mj-lt"/>
+                <a:ea typeface="Calibri" panose="020F0502020204030204" pitchFamily="34" charset="0"/>
+                <a:cs typeface="Times New Roman" panose="02020603050405020304" pitchFamily="18" charset="0"/>
+              </a:rPr>
+              <a:t>Solutions are not needed in your notebook; we will cover these during the interview.</a:t>
+            </a:r>
+            <a:endParaRPr lang="en-US" sz="1050" i="1" dirty="0">
+              <a:effectLst/>
+              <a:latin typeface="+mj-lt"/>
+              <a:ea typeface="Calibri" panose="020F0502020204030204" pitchFamily="34" charset="0"/>
+              <a:cs typeface="Times New Roman" panose="02020603050405020304" pitchFamily="18" charset="0"/>
+            </a:endParaRPr>
+          </a:p>
+          <a:p>
+            <a:pPr lvl="0">
+              <a:lnSpc>
+                <a:spcPct val="150000"/>
+              </a:lnSpc>
+            </a:pPr>
+            <a:endParaRPr lang="en-US" sz="1050" dirty="0">
+              <a:effectLst/>
+              <a:latin typeface="+mj-lt"/>
+              <a:ea typeface="Calibri" panose="020F0502020204030204" pitchFamily="34" charset="0"/>
+              <a:cs typeface="Times New Roman" panose="02020603050405020304" pitchFamily="18" charset="0"/>
+            </a:endParaRPr>
+          </a:p>
+          <a:p>
             <a:pPr marL="342900" lvl="0" indent="-342900">
               <a:lnSpc>
                 <a:spcPct val="150000"/>
@@ -5287,24 +5189,24 @@
                 <a:ea typeface="Calibri" panose="020F0502020204030204" pitchFamily="34" charset="0"/>
                 <a:cs typeface="Times New Roman" panose="02020603050405020304" pitchFamily="18" charset="0"/>
               </a:rPr>
-              <a:t>Managers of The Organization would like to see summaries of the text answers of their employees to provide (these are not included in the </a:t>
-            </a:r>
-            <a:r>
-              <a:rPr lang="en-US" sz="1050" dirty="0">
-                <a:latin typeface="+mj-lt"/>
-                <a:ea typeface="Calibri" panose="020F0502020204030204" pitchFamily="34" charset="0"/>
-                <a:cs typeface="Times New Roman" panose="02020603050405020304" pitchFamily="18" charset="0"/>
-              </a:rPr>
-              <a:t>survey results data</a:t>
-            </a:r>
-            <a:r>
+              <a:t>Next Survey Recommendations</a:t>
+            </a:r>
+            <a:br>
               <a:rPr lang="en-US" sz="1050" dirty="0">
                 <a:effectLst/>
                 <a:latin typeface="+mj-lt"/>
                 <a:ea typeface="Calibri" panose="020F0502020204030204" pitchFamily="34" charset="0"/>
                 <a:cs typeface="Times New Roman" panose="02020603050405020304" pitchFamily="18" charset="0"/>
               </a:rPr>
-              <a:t> file you received).</a:t>
+            </a:br>
+            <a:r>
+              <a:rPr lang="en-US" sz="1050" dirty="0">
+                <a:effectLst/>
+                <a:latin typeface="+mj-lt"/>
+                <a:ea typeface="Calibri" panose="020F0502020204030204" pitchFamily="34" charset="0"/>
+                <a:cs typeface="Times New Roman" panose="02020603050405020304" pitchFamily="18" charset="0"/>
+              </a:rPr>
+              <a:t>Based on areas for improvement, what recommendations would you give for a deeper dive in the next survey?</a:t>
             </a:r>
           </a:p>
           <a:p>
@@ -5322,28 +5224,59 @@
                 <a:ea typeface="Calibri" panose="020F0502020204030204" pitchFamily="34" charset="0"/>
                 <a:cs typeface="Times New Roman" panose="02020603050405020304" pitchFamily="18" charset="0"/>
               </a:rPr>
-              <a:t>Based on the discovered areas for improvement of this survey, managers of the Organization would like to have recommendations for a deep dive into the topics for their next survey.</a:t>
-            </a:r>
-          </a:p>
-          <a:p>
-            <a:pPr marL="342900" lvl="0" indent="-342900">
-              <a:lnSpc>
-                <a:spcPct val="150000"/>
-              </a:lnSpc>
-              <a:spcAft>
-                <a:spcPts val="800"/>
-              </a:spcAft>
-              <a:buFont typeface="+mj-lt"/>
-              <a:buAutoNum type="arabicPeriod"/>
-            </a:pPr>
-            <a:r>
+              <a:t>Scalable Solutions</a:t>
+            </a:r>
+            <a:br>
               <a:rPr lang="en-US" sz="1050" dirty="0">
                 <a:effectLst/>
                 <a:latin typeface="+mj-lt"/>
                 <a:ea typeface="Calibri" panose="020F0502020204030204" pitchFamily="34" charset="0"/>
                 <a:cs typeface="Times New Roman" panose="02020603050405020304" pitchFamily="18" charset="0"/>
               </a:rPr>
-              <a:t>Effectory is getting similar requests from clients quite frequently. How would you enable all of these extra features on the results of the survey for all of our clients?</a:t>
+            </a:br>
+            <a:r>
+              <a:rPr lang="en-US" sz="1050" dirty="0">
+                <a:effectLst/>
+                <a:latin typeface="+mj-lt"/>
+                <a:ea typeface="Calibri" panose="020F0502020204030204" pitchFamily="34" charset="0"/>
+                <a:cs typeface="Times New Roman" panose="02020603050405020304" pitchFamily="18" charset="0"/>
+              </a:rPr>
+              <a:t>Effectory receives similar requests frequently. How would you design a scalable solution to deliver these advanced features across all clients?</a:t>
+            </a:r>
+          </a:p>
+          <a:p>
+            <a:pPr marL="342900" lvl="0" indent="-342900">
+              <a:lnSpc>
+                <a:spcPct val="150000"/>
+              </a:lnSpc>
+              <a:buFont typeface="+mj-lt"/>
+              <a:buAutoNum type="arabicPeriod"/>
+            </a:pPr>
+            <a:r>
+              <a:rPr lang="en-US" sz="1050" dirty="0">
+                <a:effectLst/>
+                <a:latin typeface="+mj-lt"/>
+                <a:ea typeface="Calibri" panose="020F0502020204030204" pitchFamily="34" charset="0"/>
+                <a:cs typeface="Times New Roman" panose="02020603050405020304" pitchFamily="18" charset="0"/>
+              </a:rPr>
+              <a:t>Advanced AI Integration</a:t>
+            </a:r>
+            <a:br>
+              <a:rPr lang="en-US" sz="1050" dirty="0">
+                <a:effectLst/>
+                <a:latin typeface="+mj-lt"/>
+                <a:ea typeface="Calibri" panose="020F0502020204030204" pitchFamily="34" charset="0"/>
+                <a:cs typeface="Times New Roman" panose="02020603050405020304" pitchFamily="18" charset="0"/>
+              </a:rPr>
+            </a:br>
+            <a:r>
+              <a:rPr lang="en-US" sz="1050" dirty="0">
+                <a:effectLst/>
+                <a:latin typeface="+mj-lt"/>
+                <a:ea typeface="Calibri" panose="020F0502020204030204" pitchFamily="34" charset="0"/>
+                <a:cs typeface="Times New Roman" panose="02020603050405020304" pitchFamily="18" charset="0"/>
+              </a:rPr>
+              <a:t>How would you use LLMs or other AI techniques to generate actionable recommendations, combine structured and unstructured data, and deliver insights that go beyond what a generic ChatGPT analysis could provide?</a:t>
             </a:r>
           </a:p>
         </p:txBody>
@@ -5957,6 +5890,19 @@
 </file>
 
 <file path=customXml/item2.xml><?xml version="1.0" encoding="utf-8"?>
+<p:properties xmlns:p="http://schemas.microsoft.com/office/2006/metadata/properties" xmlns:xsi="http://www.w3.org/2001/XMLSchema-instance" xmlns:pc="http://schemas.microsoft.com/office/infopath/2007/PartnerControls">
+  <documentManagement>
+    <_ip_UnifiedCompliancePolicyUIAction xmlns="http://schemas.microsoft.com/sharepoint/v3" xsi:nil="true"/>
+    <_ip_UnifiedCompliancePolicyProperties xmlns="http://schemas.microsoft.com/sharepoint/v3" xsi:nil="true"/>
+    <lcf76f155ced4ddcb4097134ff3c332f xmlns="01edf75c-d75d-4b03-809c-e03782485d8f">
+      <Terms xmlns="http://schemas.microsoft.com/office/infopath/2007/PartnerControls"/>
+    </lcf76f155ced4ddcb4097134ff3c332f>
+    <TaxCatchAll xmlns="4288ad3f-a146-471b-a9ac-b245f9eebc3a" xsi:nil="true"/>
+  </documentManagement>
+</p:properties>
+</file>
+
+<file path=customXml/item3.xml><?xml version="1.0" encoding="utf-8"?>
 <ct:contentTypeSchema xmlns:ct="http://schemas.microsoft.com/office/2006/metadata/contentType" xmlns:ma="http://schemas.microsoft.com/office/2006/metadata/properties/metaAttributes" ct:_="" ma:_="" ma:contentTypeName="Document" ma:contentTypeID="0x0101001E20A90A24610848AEEAE2F8CD47FA91" ma:contentTypeVersion="19" ma:contentTypeDescription="Een nieuw document maken." ma:contentTypeScope="" ma:versionID="147309765e6e15e928bcf2c9a9add6d5">
   <xsd:schema xmlns:xsd="http://www.w3.org/2001/XMLSchema" xmlns:xs="http://www.w3.org/2001/XMLSchema" xmlns:p="http://schemas.microsoft.com/office/2006/metadata/properties" xmlns:ns1="http://schemas.microsoft.com/sharepoint/v3" xmlns:ns2="4288ad3f-a146-471b-a9ac-b245f9eebc3a" xmlns:ns3="01edf75c-d75d-4b03-809c-e03782485d8f" targetNamespace="http://schemas.microsoft.com/office/2006/metadata/properties" ma:root="true" ma:fieldsID="6e8fbd19cdddabbef419068e04ae5138" ns1:_="" ns2:_="" ns3:_="">
     <xsd:import namespace="http://schemas.microsoft.com/sharepoint/v3"/>
@@ -6222,19 +6168,6 @@
 </ct:contentTypeSchema>
 </file>
 
-<file path=customXml/item3.xml><?xml version="1.0" encoding="utf-8"?>
-<p:properties xmlns:p="http://schemas.microsoft.com/office/2006/metadata/properties" xmlns:xsi="http://www.w3.org/2001/XMLSchema-instance" xmlns:pc="http://schemas.microsoft.com/office/infopath/2007/PartnerControls">
-  <documentManagement>
-    <_ip_UnifiedCompliancePolicyUIAction xmlns="http://schemas.microsoft.com/sharepoint/v3" xsi:nil="true"/>
-    <_ip_UnifiedCompliancePolicyProperties xmlns="http://schemas.microsoft.com/sharepoint/v3" xsi:nil="true"/>
-    <lcf76f155ced4ddcb4097134ff3c332f xmlns="01edf75c-d75d-4b03-809c-e03782485d8f">
-      <Terms xmlns="http://schemas.microsoft.com/office/infopath/2007/PartnerControls"/>
-    </lcf76f155ced4ddcb4097134ff3c332f>
-    <TaxCatchAll xmlns="4288ad3f-a146-471b-a9ac-b245f9eebc3a" xsi:nil="true"/>
-  </documentManagement>
-</p:properties>
-</file>
-
 <file path=customXml/itemProps1.xml><?xml version="1.0" encoding="utf-8"?>
 <ds:datastoreItem xmlns:ds="http://schemas.openxmlformats.org/officeDocument/2006/customXml" ds:itemID="{E024892C-DE71-4591-BA90-D81858F9526C}">
   <ds:schemaRefs>
@@ -6244,6 +6177,26 @@
 </file>
 
 <file path=customXml/itemProps2.xml><?xml version="1.0" encoding="utf-8"?>
+<ds:datastoreItem xmlns:ds="http://schemas.openxmlformats.org/officeDocument/2006/customXml" ds:itemID="{49D510B8-9C8F-4587-97D1-0D231C65BF0A}">
+  <ds:schemaRefs>
+    <ds:schemaRef ds:uri="3f2d3da5-b56a-475f-9352-0ef62559252e"/>
+    <ds:schemaRef ds:uri="a5518822-07d6-4741-b9a6-88e6aef166b8"/>
+    <ds:schemaRef ds:uri="http://purl.org/dc/dcmitype/"/>
+    <ds:schemaRef ds:uri="http://purl.org/dc/elements/1.1/"/>
+    <ds:schemaRef ds:uri="http://purl.org/dc/terms/"/>
+    <ds:schemaRef ds:uri="http://schemas.microsoft.com/office/2006/documentManagement/types"/>
+    <ds:schemaRef ds:uri="http://schemas.microsoft.com/office/2006/metadata/properties"/>
+    <ds:schemaRef ds:uri="http://schemas.microsoft.com/office/infopath/2007/PartnerControls"/>
+    <ds:schemaRef ds:uri="http://schemas.microsoft.com/sharepoint/v3"/>
+    <ds:schemaRef ds:uri="http://schemas.openxmlformats.org/package/2006/metadata/core-properties"/>
+    <ds:schemaRef ds:uri="http://www.w3.org/XML/1998/namespace"/>
+    <ds:schemaRef ds:uri="01edf75c-d75d-4b03-809c-e03782485d8f"/>
+    <ds:schemaRef ds:uri="4288ad3f-a146-471b-a9ac-b245f9eebc3a"/>
+  </ds:schemaRefs>
+</ds:datastoreItem>
+</file>
+
+<file path=customXml/itemProps3.xml><?xml version="1.0" encoding="utf-8"?>
 <ds:datastoreItem xmlns:ds="http://schemas.openxmlformats.org/officeDocument/2006/customXml" ds:itemID="{D0EA6AF3-4774-4D63-9A92-60765AD5528A}">
   <ds:schemaRefs>
     <ds:schemaRef ds:uri="http://schemas.microsoft.com/office/2006/metadata/contentType"/>
@@ -6263,26 +6216,6 @@
 </ds:datastoreItem>
 </file>
 
-<file path=customXml/itemProps3.xml><?xml version="1.0" encoding="utf-8"?>
-<ds:datastoreItem xmlns:ds="http://schemas.openxmlformats.org/officeDocument/2006/customXml" ds:itemID="{49D510B8-9C8F-4587-97D1-0D231C65BF0A}">
-  <ds:schemaRefs>
-    <ds:schemaRef ds:uri="3f2d3da5-b56a-475f-9352-0ef62559252e"/>
-    <ds:schemaRef ds:uri="a5518822-07d6-4741-b9a6-88e6aef166b8"/>
-    <ds:schemaRef ds:uri="http://purl.org/dc/dcmitype/"/>
-    <ds:schemaRef ds:uri="http://purl.org/dc/elements/1.1/"/>
-    <ds:schemaRef ds:uri="http://purl.org/dc/terms/"/>
-    <ds:schemaRef ds:uri="http://schemas.microsoft.com/office/2006/documentManagement/types"/>
-    <ds:schemaRef ds:uri="http://schemas.microsoft.com/office/2006/metadata/properties"/>
-    <ds:schemaRef ds:uri="http://schemas.microsoft.com/office/infopath/2007/PartnerControls"/>
-    <ds:schemaRef ds:uri="http://schemas.microsoft.com/sharepoint/v3"/>
-    <ds:schemaRef ds:uri="http://schemas.openxmlformats.org/package/2006/metadata/core-properties"/>
-    <ds:schemaRef ds:uri="http://www.w3.org/XML/1998/namespace"/>
-    <ds:schemaRef ds:uri="01edf75c-d75d-4b03-809c-e03782485d8f"/>
-    <ds:schemaRef ds:uri="4288ad3f-a146-471b-a9ac-b245f9eebc3a"/>
-  </ds:schemaRefs>
-</ds:datastoreItem>
-</file>
-
 <file path=docMetadata/LabelInfo.xml><?xml version="1.0" encoding="utf-8"?>
 <clbl:labelList xmlns:clbl="http://schemas.microsoft.com/office/2020/mipLabelMetadata">
   <clbl:label id="{b460a816-67c7-40fa-b867-381aebecaa74}" enabled="1" method="Privileged" siteId="{e9792fd7-4044-47e7-a40d-3fba46f1cd09}" removed="0"/>

</xml_diff>